<commit_message>
Optimize write engine and add SLVERR on early WLAST - Pop next AW entry directly from W_RESP on B handshake so back-to-back   bursts skip the idle cycle. - Factor the AW FIFO pop into a pop() task shared by W_IDLE and W_RESP. - Respond SLVERR when the master asserts WLAST before the final beat. - Add 16 dbg_regN observation ports on the slave and wire them in the tb.
</commit_message>
<xml_diff>
--- a/doc/AXI.pptx
+++ b/doc/AXI.pptx
@@ -7,6 +7,10 @@
   <p:sldIdLst>
     <p:sldId id="256" r:id="rId2"/>
     <p:sldId id="257" r:id="rId3"/>
+    <p:sldId id="258" r:id="rId4"/>
+    <p:sldId id="259" r:id="rId5"/>
+    <p:sldId id="260" r:id="rId6"/>
+    <p:sldId id="261" r:id="rId7"/>
   </p:sldIdLst>
   <p:sldSz cx="12192000" cy="6858000"/>
   <p:notesSz cx="6858000" cy="9144000"/>
@@ -3451,6 +3455,247 @@
 </p:sld>
 </file>
 
+<file path=ppt/slides/slide3.xml><?xml version="1.0" encoding="utf-8"?>
+<p:sld xmlns:a="http://schemas.openxmlformats.org/drawingml/2006/main" xmlns:r="http://schemas.openxmlformats.org/officeDocument/2006/relationships" xmlns:p="http://schemas.openxmlformats.org/presentationml/2006/main">
+  <p:cSld>
+    <p:spTree>
+      <p:nvGrpSpPr>
+        <p:cNvPr id="1" name=""/>
+        <p:cNvGrpSpPr/>
+        <p:nvPr/>
+      </p:nvGrpSpPr>
+      <p:grpSpPr>
+        <a:xfrm>
+          <a:off x="0" y="0"/>
+          <a:ext cx="0" cy="0"/>
+          <a:chOff x="0" y="0"/>
+          <a:chExt cx="0" cy="0"/>
+        </a:xfrm>
+      </p:grpSpPr>
+      <p:pic>
+        <p:nvPicPr>
+          <p:cNvPr id="5" name="Picture 4">
+            <a:extLst>
+              <a:ext uri="{FF2B5EF4-FFF2-40B4-BE49-F238E27FC236}">
+                <a16:creationId xmlns:a16="http://schemas.microsoft.com/office/drawing/2014/main" id="{0C3AE289-1159-C9B3-B65E-E06B86D6CF72}"/>
+              </a:ext>
+            </a:extLst>
+          </p:cNvPr>
+          <p:cNvPicPr>
+            <a:picLocks noChangeAspect="1"/>
+          </p:cNvPicPr>
+          <p:nvPr/>
+        </p:nvPicPr>
+        <p:blipFill>
+          <a:blip r:embed="rId2"/>
+          <a:srcRect r="1205"/>
+          <a:stretch>
+            <a:fillRect/>
+          </a:stretch>
+        </p:blipFill>
+        <p:spPr>
+          <a:xfrm>
+            <a:off x="512858" y="440267"/>
+            <a:ext cx="11006727" cy="6273800"/>
+          </a:xfrm>
+          <a:prstGeom prst="rect">
+            <a:avLst/>
+          </a:prstGeom>
+        </p:spPr>
+      </p:pic>
+    </p:spTree>
+    <p:extLst>
+      <p:ext uri="{BB962C8B-B14F-4D97-AF65-F5344CB8AC3E}">
+        <p14:creationId xmlns:p14="http://schemas.microsoft.com/office/powerpoint/2010/main" val="3786220653"/>
+      </p:ext>
+    </p:extLst>
+  </p:cSld>
+  <p:clrMapOvr>
+    <a:masterClrMapping/>
+  </p:clrMapOvr>
+</p:sld>
+</file>
+
+<file path=ppt/slides/slide4.xml><?xml version="1.0" encoding="utf-8"?>
+<p:sld xmlns:a="http://schemas.openxmlformats.org/drawingml/2006/main" xmlns:r="http://schemas.openxmlformats.org/officeDocument/2006/relationships" xmlns:p="http://schemas.openxmlformats.org/presentationml/2006/main">
+  <p:cSld>
+    <p:spTree>
+      <p:nvGrpSpPr>
+        <p:cNvPr id="1" name=""/>
+        <p:cNvGrpSpPr/>
+        <p:nvPr/>
+      </p:nvGrpSpPr>
+      <p:grpSpPr>
+        <a:xfrm>
+          <a:off x="0" y="0"/>
+          <a:ext cx="0" cy="0"/>
+          <a:chOff x="0" y="0"/>
+          <a:chExt cx="0" cy="0"/>
+        </a:xfrm>
+      </p:grpSpPr>
+      <p:pic>
+        <p:nvPicPr>
+          <p:cNvPr id="3" name="Picture 2">
+            <a:extLst>
+              <a:ext uri="{FF2B5EF4-FFF2-40B4-BE49-F238E27FC236}">
+                <a16:creationId xmlns:a16="http://schemas.microsoft.com/office/drawing/2014/main" id="{3A2891FA-7498-9CC4-39CA-0E120C9D8F2C}"/>
+              </a:ext>
+            </a:extLst>
+          </p:cNvPr>
+          <p:cNvPicPr>
+            <a:picLocks noChangeAspect="1"/>
+          </p:cNvPicPr>
+          <p:nvPr/>
+        </p:nvPicPr>
+        <p:blipFill>
+          <a:blip r:embed="rId2"/>
+          <a:stretch>
+            <a:fillRect/>
+          </a:stretch>
+        </p:blipFill>
+        <p:spPr>
+          <a:xfrm>
+            <a:off x="439369" y="588126"/>
+            <a:ext cx="11313261" cy="6066531"/>
+          </a:xfrm>
+          <a:prstGeom prst="rect">
+            <a:avLst/>
+          </a:prstGeom>
+        </p:spPr>
+      </p:pic>
+    </p:spTree>
+    <p:extLst>
+      <p:ext uri="{BB962C8B-B14F-4D97-AF65-F5344CB8AC3E}">
+        <p14:creationId xmlns:p14="http://schemas.microsoft.com/office/powerpoint/2010/main" val="2447764043"/>
+      </p:ext>
+    </p:extLst>
+  </p:cSld>
+  <p:clrMapOvr>
+    <a:masterClrMapping/>
+  </p:clrMapOvr>
+</p:sld>
+</file>
+
+<file path=ppt/slides/slide5.xml><?xml version="1.0" encoding="utf-8"?>
+<p:sld xmlns:a="http://schemas.openxmlformats.org/drawingml/2006/main" xmlns:r="http://schemas.openxmlformats.org/officeDocument/2006/relationships" xmlns:p="http://schemas.openxmlformats.org/presentationml/2006/main">
+  <p:cSld>
+    <p:spTree>
+      <p:nvGrpSpPr>
+        <p:cNvPr id="1" name=""/>
+        <p:cNvGrpSpPr/>
+        <p:nvPr/>
+      </p:nvGrpSpPr>
+      <p:grpSpPr>
+        <a:xfrm>
+          <a:off x="0" y="0"/>
+          <a:ext cx="0" cy="0"/>
+          <a:chOff x="0" y="0"/>
+          <a:chExt cx="0" cy="0"/>
+        </a:xfrm>
+      </p:grpSpPr>
+      <p:pic>
+        <p:nvPicPr>
+          <p:cNvPr id="3" name="Picture 2">
+            <a:extLst>
+              <a:ext uri="{FF2B5EF4-FFF2-40B4-BE49-F238E27FC236}">
+                <a16:creationId xmlns:a16="http://schemas.microsoft.com/office/drawing/2014/main" id="{44B75E4A-616F-C07D-93C2-0E42C8E10E31}"/>
+              </a:ext>
+            </a:extLst>
+          </p:cNvPr>
+          <p:cNvPicPr>
+            <a:picLocks noChangeAspect="1"/>
+          </p:cNvPicPr>
+          <p:nvPr/>
+        </p:nvPicPr>
+        <p:blipFill>
+          <a:blip r:embed="rId2"/>
+          <a:stretch>
+            <a:fillRect/>
+          </a:stretch>
+        </p:blipFill>
+        <p:spPr>
+          <a:xfrm>
+            <a:off x="896934" y="745067"/>
+            <a:ext cx="10638565" cy="5833389"/>
+          </a:xfrm>
+          <a:prstGeom prst="rect">
+            <a:avLst/>
+          </a:prstGeom>
+        </p:spPr>
+      </p:pic>
+    </p:spTree>
+    <p:extLst>
+      <p:ext uri="{BB962C8B-B14F-4D97-AF65-F5344CB8AC3E}">
+        <p14:creationId xmlns:p14="http://schemas.microsoft.com/office/powerpoint/2010/main" val="4186278016"/>
+      </p:ext>
+    </p:extLst>
+  </p:cSld>
+  <p:clrMapOvr>
+    <a:masterClrMapping/>
+  </p:clrMapOvr>
+</p:sld>
+</file>
+
+<file path=ppt/slides/slide6.xml><?xml version="1.0" encoding="utf-8"?>
+<p:sld xmlns:a="http://schemas.openxmlformats.org/drawingml/2006/main" xmlns:r="http://schemas.openxmlformats.org/officeDocument/2006/relationships" xmlns:p="http://schemas.openxmlformats.org/presentationml/2006/main">
+  <p:cSld>
+    <p:spTree>
+      <p:nvGrpSpPr>
+        <p:cNvPr id="1" name=""/>
+        <p:cNvGrpSpPr/>
+        <p:nvPr/>
+      </p:nvGrpSpPr>
+      <p:grpSpPr>
+        <a:xfrm>
+          <a:off x="0" y="0"/>
+          <a:ext cx="0" cy="0"/>
+          <a:chOff x="0" y="0"/>
+          <a:chExt cx="0" cy="0"/>
+        </a:xfrm>
+      </p:grpSpPr>
+      <p:pic>
+        <p:nvPicPr>
+          <p:cNvPr id="3" name="Picture 2">
+            <a:extLst>
+              <a:ext uri="{FF2B5EF4-FFF2-40B4-BE49-F238E27FC236}">
+                <a16:creationId xmlns:a16="http://schemas.microsoft.com/office/drawing/2014/main" id="{DE04FBFB-F07F-58DA-E887-DDFE15A84146}"/>
+              </a:ext>
+            </a:extLst>
+          </p:cNvPr>
+          <p:cNvPicPr>
+            <a:picLocks noChangeAspect="1"/>
+          </p:cNvPicPr>
+          <p:nvPr/>
+        </p:nvPicPr>
+        <p:blipFill>
+          <a:blip r:embed="rId2"/>
+          <a:stretch>
+            <a:fillRect/>
+          </a:stretch>
+        </p:blipFill>
+        <p:spPr>
+          <a:xfrm>
+            <a:off x="872254" y="711200"/>
+            <a:ext cx="10447491" cy="5924768"/>
+          </a:xfrm>
+          <a:prstGeom prst="rect">
+            <a:avLst/>
+          </a:prstGeom>
+        </p:spPr>
+      </p:pic>
+    </p:spTree>
+    <p:extLst>
+      <p:ext uri="{BB962C8B-B14F-4D97-AF65-F5344CB8AC3E}">
+        <p14:creationId xmlns:p14="http://schemas.microsoft.com/office/powerpoint/2010/main" val="3190925855"/>
+      </p:ext>
+    </p:extLst>
+  </p:cSld>
+  <p:clrMapOvr>
+    <a:masterClrMapping/>
+  </p:clrMapOvr>
+</p:sld>
+</file>
+
 <file path=ppt/theme/theme1.xml><?xml version="1.0" encoding="utf-8"?>
 <a:theme xmlns:a="http://schemas.openxmlformats.org/drawingml/2006/main" name="Office Theme">
   <a:themeElements>

</xml_diff>

<commit_message>
Add error slave for illegal bursts (DECERR)
- New err_slave.sv: terminates decoder-flagged illegal bursts (address
  outside every slave window, end address crossing the window, or a
  non-INCR burst type). Drains every beat per the AXI no-early-burst-
  termination rule and answers DECERR; termination is counter-driven so
  a missing WLAST cannot hang it.
- New err_slave_tb.sv covering single-beat, 4-beat, and missing-WLAST cases.
- Add RESP_DECERR (2'b11) to axi_params.svh.
- Restore the timeout watchdog in slavetb.sv.
</commit_message>
<xml_diff>
--- a/doc/AXI.pptx
+++ b/doc/AXI.pptx
@@ -11,6 +11,7 @@
     <p:sldId id="259" r:id="rId5"/>
     <p:sldId id="260" r:id="rId6"/>
     <p:sldId id="261" r:id="rId7"/>
+    <p:sldId id="262" r:id="rId8"/>
   </p:sldIdLst>
   <p:sldSz cx="12192000" cy="6858000"/>
   <p:notesSz cx="6858000" cy="9144000"/>
@@ -3696,6 +3697,66 @@
 </p:sld>
 </file>
 
+<file path=ppt/slides/slide7.xml><?xml version="1.0" encoding="utf-8"?>
+<p:sld xmlns:a="http://schemas.openxmlformats.org/drawingml/2006/main" xmlns:r="http://schemas.openxmlformats.org/officeDocument/2006/relationships" xmlns:p="http://schemas.openxmlformats.org/presentationml/2006/main">
+  <p:cSld>
+    <p:spTree>
+      <p:nvGrpSpPr>
+        <p:cNvPr id="1" name=""/>
+        <p:cNvGrpSpPr/>
+        <p:nvPr/>
+      </p:nvGrpSpPr>
+      <p:grpSpPr>
+        <a:xfrm>
+          <a:off x="0" y="0"/>
+          <a:ext cx="0" cy="0"/>
+          <a:chOff x="0" y="0"/>
+          <a:chExt cx="0" cy="0"/>
+        </a:xfrm>
+      </p:grpSpPr>
+      <p:pic>
+        <p:nvPicPr>
+          <p:cNvPr id="3" name="Picture 2">
+            <a:extLst>
+              <a:ext uri="{FF2B5EF4-FFF2-40B4-BE49-F238E27FC236}">
+                <a16:creationId xmlns:a16="http://schemas.microsoft.com/office/drawing/2014/main" id="{C7FB7613-606A-E05B-BCE7-6AB1830B1F31}"/>
+              </a:ext>
+            </a:extLst>
+          </p:cNvPr>
+          <p:cNvPicPr>
+            <a:picLocks noChangeAspect="1"/>
+          </p:cNvPicPr>
+          <p:nvPr/>
+        </p:nvPicPr>
+        <p:blipFill>
+          <a:blip r:embed="rId2"/>
+          <a:stretch>
+            <a:fillRect/>
+          </a:stretch>
+        </p:blipFill>
+        <p:spPr>
+          <a:xfrm>
+            <a:off x="387094" y="953913"/>
+            <a:ext cx="11417812" cy="4950174"/>
+          </a:xfrm>
+          <a:prstGeom prst="rect">
+            <a:avLst/>
+          </a:prstGeom>
+        </p:spPr>
+      </p:pic>
+    </p:spTree>
+    <p:extLst>
+      <p:ext uri="{BB962C8B-B14F-4D97-AF65-F5344CB8AC3E}">
+        <p14:creationId xmlns:p14="http://schemas.microsoft.com/office/powerpoint/2010/main" val="4107629951"/>
+      </p:ext>
+    </p:extLst>
+  </p:cSld>
+  <p:clrMapOvr>
+    <a:masterClrMapping/>
+  </p:clrMapOvr>
+</p:sld>
+</file>
+
 <file path=ppt/theme/theme1.xml><?xml version="1.0" encoding="utf-8"?>
 <a:theme xmlns:a="http://schemas.openxmlformats.org/drawingml/2006/main" name="Office Theme">
   <a:themeElements>

</xml_diff>

<commit_message>
Add decoder and arbiter and update previous files and a master skid slice
</commit_message>
<xml_diff>
--- a/doc/AXI.pptx
+++ b/doc/AXI.pptx
@@ -6,12 +6,14 @@
   </p:sldMasterIdLst>
   <p:sldIdLst>
     <p:sldId id="256" r:id="rId2"/>
-    <p:sldId id="257" r:id="rId3"/>
-    <p:sldId id="258" r:id="rId4"/>
-    <p:sldId id="259" r:id="rId5"/>
-    <p:sldId id="260" r:id="rId6"/>
-    <p:sldId id="261" r:id="rId7"/>
-    <p:sldId id="262" r:id="rId8"/>
+    <p:sldId id="258" r:id="rId3"/>
+    <p:sldId id="259" r:id="rId4"/>
+    <p:sldId id="260" r:id="rId5"/>
+    <p:sldId id="261" r:id="rId6"/>
+    <p:sldId id="262" r:id="rId7"/>
+    <p:sldId id="257" r:id="rId8"/>
+    <p:sldId id="263" r:id="rId9"/>
+    <p:sldId id="264" r:id="rId10"/>
   </p:sldIdLst>
   <p:sldSz cx="12192000" cy="6858000"/>
   <p:notesSz cx="6858000" cy="9144000"/>
@@ -110,6 +112,11 @@
       </a:defRPr>
     </a:lvl9pPr>
   </p:defaultTextStyle>
+  <p:extLst>
+    <p:ext uri="{EFAFB233-063F-42B5-8137-9DF3F51BA10A}">
+      <p15:sldGuideLst xmlns:p15="http://schemas.microsoft.com/office/powerpoint/2012/main"/>
+    </p:ext>
+  </p:extLst>
 </p:presentation>
 </file>
 
@@ -260,7 +267,7 @@
           <a:p>
             <a:fld id="{F120C451-DCB1-4D59-8D1B-95032E339999}" type="datetimeFigureOut">
               <a:rPr lang="en-US" smtClean="0"/>
-              <a:t>8/12/2026</a:t>
+              <a:t>8/18/2026</a:t>
             </a:fld>
             <a:endParaRPr lang="en-US"/>
           </a:p>
@@ -458,7 +465,7 @@
           <a:p>
             <a:fld id="{F120C451-DCB1-4D59-8D1B-95032E339999}" type="datetimeFigureOut">
               <a:rPr lang="en-US" smtClean="0"/>
-              <a:t>8/12/2026</a:t>
+              <a:t>8/18/2026</a:t>
             </a:fld>
             <a:endParaRPr lang="en-US"/>
           </a:p>
@@ -666,7 +673,7 @@
           <a:p>
             <a:fld id="{F120C451-DCB1-4D59-8D1B-95032E339999}" type="datetimeFigureOut">
               <a:rPr lang="en-US" smtClean="0"/>
-              <a:t>8/12/2026</a:t>
+              <a:t>8/18/2026</a:t>
             </a:fld>
             <a:endParaRPr lang="en-US"/>
           </a:p>
@@ -864,7 +871,7 @@
           <a:p>
             <a:fld id="{F120C451-DCB1-4D59-8D1B-95032E339999}" type="datetimeFigureOut">
               <a:rPr lang="en-US" smtClean="0"/>
-              <a:t>8/12/2026</a:t>
+              <a:t>8/18/2026</a:t>
             </a:fld>
             <a:endParaRPr lang="en-US"/>
           </a:p>
@@ -1139,7 +1146,7 @@
           <a:p>
             <a:fld id="{F120C451-DCB1-4D59-8D1B-95032E339999}" type="datetimeFigureOut">
               <a:rPr lang="en-US" smtClean="0"/>
-              <a:t>8/12/2026</a:t>
+              <a:t>8/18/2026</a:t>
             </a:fld>
             <a:endParaRPr lang="en-US"/>
           </a:p>
@@ -1404,7 +1411,7 @@
           <a:p>
             <a:fld id="{F120C451-DCB1-4D59-8D1B-95032E339999}" type="datetimeFigureOut">
               <a:rPr lang="en-US" smtClean="0"/>
-              <a:t>8/12/2026</a:t>
+              <a:t>8/18/2026</a:t>
             </a:fld>
             <a:endParaRPr lang="en-US"/>
           </a:p>
@@ -1816,7 +1823,7 @@
           <a:p>
             <a:fld id="{F120C451-DCB1-4D59-8D1B-95032E339999}" type="datetimeFigureOut">
               <a:rPr lang="en-US" smtClean="0"/>
-              <a:t>8/12/2026</a:t>
+              <a:t>8/18/2026</a:t>
             </a:fld>
             <a:endParaRPr lang="en-US"/>
           </a:p>
@@ -1957,7 +1964,7 @@
           <a:p>
             <a:fld id="{F120C451-DCB1-4D59-8D1B-95032E339999}" type="datetimeFigureOut">
               <a:rPr lang="en-US" smtClean="0"/>
-              <a:t>8/12/2026</a:t>
+              <a:t>8/18/2026</a:t>
             </a:fld>
             <a:endParaRPr lang="en-US"/>
           </a:p>
@@ -2070,7 +2077,7 @@
           <a:p>
             <a:fld id="{F120C451-DCB1-4D59-8D1B-95032E339999}" type="datetimeFigureOut">
               <a:rPr lang="en-US" smtClean="0"/>
-              <a:t>8/12/2026</a:t>
+              <a:t>8/18/2026</a:t>
             </a:fld>
             <a:endParaRPr lang="en-US"/>
           </a:p>
@@ -2381,7 +2388,7 @@
           <a:p>
             <a:fld id="{F120C451-DCB1-4D59-8D1B-95032E339999}" type="datetimeFigureOut">
               <a:rPr lang="en-US" smtClean="0"/>
-              <a:t>8/12/2026</a:t>
+              <a:t>8/18/2026</a:t>
             </a:fld>
             <a:endParaRPr lang="en-US"/>
           </a:p>
@@ -2669,7 +2676,7 @@
           <a:p>
             <a:fld id="{F120C451-DCB1-4D59-8D1B-95032E339999}" type="datetimeFigureOut">
               <a:rPr lang="en-US" smtClean="0"/>
-              <a:t>8/12/2026</a:t>
+              <a:t>8/18/2026</a:t>
             </a:fld>
             <a:endParaRPr lang="en-US"/>
           </a:p>
@@ -2910,7 +2917,7 @@
           <a:p>
             <a:fld id="{F120C451-DCB1-4D59-8D1B-95032E339999}" type="datetimeFigureOut">
               <a:rPr lang="en-US" smtClean="0"/>
-              <a:t>8/12/2026</a:t>
+              <a:t>8/18/2026</a:t>
             </a:fld>
             <a:endParaRPr lang="en-US"/>
           </a:p>
@@ -3409,10 +3416,10 @@
       </p:grpSpPr>
       <p:pic>
         <p:nvPicPr>
-          <p:cNvPr id="3" name="Picture 2">
-            <a:extLst>
-              <a:ext uri="{FF2B5EF4-FFF2-40B4-BE49-F238E27FC236}">
-                <a16:creationId xmlns:a16="http://schemas.microsoft.com/office/drawing/2014/main" id="{E2B3E252-6341-0D0B-472D-04B8DFFA4680}"/>
+          <p:cNvPr id="5" name="Picture 4">
+            <a:extLst>
+              <a:ext uri="{FF2B5EF4-FFF2-40B4-BE49-F238E27FC236}">
+                <a16:creationId xmlns:a16="http://schemas.microsoft.com/office/drawing/2014/main" id="{0C3AE289-1159-C9B3-B65E-E06B86D6CF72}"/>
               </a:ext>
             </a:extLst>
           </p:cNvPr>
@@ -3422,31 +3429,64 @@
           <p:nvPr/>
         </p:nvPicPr>
         <p:blipFill>
-          <a:blip r:embed="rId2">
-            <a:extLst>
-              <a:ext uri="{28A0092B-C50C-407E-A947-70E740481C1C}">
-                <a14:useLocalDpi xmlns:a14="http://schemas.microsoft.com/office/drawing/2010/main" val="0"/>
-              </a:ext>
-            </a:extLst>
-          </a:blip>
+          <a:blip r:embed="rId2"/>
+          <a:srcRect r="1205"/>
           <a:stretch>
             <a:fillRect/>
           </a:stretch>
         </p:blipFill>
         <p:spPr>
           <a:xfrm>
-            <a:off x="37731" y="1095232"/>
-            <a:ext cx="12116537" cy="4464336"/>
+            <a:off x="1149657" y="880533"/>
+            <a:ext cx="9892685" cy="5638800"/>
           </a:xfrm>
           <a:prstGeom prst="rect">
             <a:avLst/>
           </a:prstGeom>
         </p:spPr>
       </p:pic>
+      <p:sp>
+        <p:nvSpPr>
+          <p:cNvPr id="7" name="TextBox 6">
+            <a:extLst>
+              <a:ext uri="{FF2B5EF4-FFF2-40B4-BE49-F238E27FC236}">
+                <a16:creationId xmlns:a16="http://schemas.microsoft.com/office/drawing/2014/main" id="{959C20EB-2926-F06D-A85C-779000DFC3B8}"/>
+              </a:ext>
+            </a:extLst>
+          </p:cNvPr>
+          <p:cNvSpPr txBox="1"/>
+          <p:nvPr/>
+        </p:nvSpPr>
+        <p:spPr>
+          <a:xfrm>
+            <a:off x="338667" y="228600"/>
+            <a:ext cx="5757333" cy="369332"/>
+          </a:xfrm>
+          <a:prstGeom prst="rect">
+            <a:avLst/>
+          </a:prstGeom>
+          <a:noFill/>
+        </p:spPr>
+        <p:txBody>
+          <a:bodyPr wrap="square" rtlCol="0">
+            <a:spAutoFit/>
+          </a:bodyPr>
+          <a:lstStyle/>
+          <a:p>
+            <a:r>
+              <a:rPr lang="en-US" b="1" dirty="0">
+                <a:latin typeface="Times New Roman" panose="02020603050405020304" pitchFamily="18" charset="0"/>
+                <a:cs typeface="Times New Roman" panose="02020603050405020304" pitchFamily="18" charset="0"/>
+              </a:rPr>
+              <a:t>Slave single address pop – write - resp</a:t>
+            </a:r>
+          </a:p>
+        </p:txBody>
+      </p:sp>
     </p:spTree>
     <p:extLst>
       <p:ext uri="{BB962C8B-B14F-4D97-AF65-F5344CB8AC3E}">
-        <p14:creationId xmlns:p14="http://schemas.microsoft.com/office/powerpoint/2010/main" val="2865469070"/>
+        <p14:creationId xmlns:p14="http://schemas.microsoft.com/office/powerpoint/2010/main" val="3786220653"/>
       </p:ext>
     </p:extLst>
   </p:cSld>
@@ -3475,10 +3515,10 @@
       </p:grpSpPr>
       <p:pic>
         <p:nvPicPr>
-          <p:cNvPr id="5" name="Picture 4">
-            <a:extLst>
-              <a:ext uri="{FF2B5EF4-FFF2-40B4-BE49-F238E27FC236}">
-                <a16:creationId xmlns:a16="http://schemas.microsoft.com/office/drawing/2014/main" id="{0C3AE289-1159-C9B3-B65E-E06B86D6CF72}"/>
+          <p:cNvPr id="3" name="Picture 2">
+            <a:extLst>
+              <a:ext uri="{FF2B5EF4-FFF2-40B4-BE49-F238E27FC236}">
+                <a16:creationId xmlns:a16="http://schemas.microsoft.com/office/drawing/2014/main" id="{3A2891FA-7498-9CC4-39CA-0E120C9D8F2C}"/>
               </a:ext>
             </a:extLst>
           </p:cNvPr>
@@ -3489,25 +3529,62 @@
         </p:nvPicPr>
         <p:blipFill>
           <a:blip r:embed="rId2"/>
-          <a:srcRect r="1205"/>
           <a:stretch>
             <a:fillRect/>
           </a:stretch>
         </p:blipFill>
         <p:spPr>
           <a:xfrm>
-            <a:off x="512858" y="440267"/>
-            <a:ext cx="11006727" cy="6273800"/>
+            <a:off x="638785" y="768268"/>
+            <a:ext cx="10914430" cy="5852665"/>
           </a:xfrm>
           <a:prstGeom prst="rect">
             <a:avLst/>
           </a:prstGeom>
         </p:spPr>
       </p:pic>
+      <p:sp>
+        <p:nvSpPr>
+          <p:cNvPr id="5" name="TextBox 4">
+            <a:extLst>
+              <a:ext uri="{FF2B5EF4-FFF2-40B4-BE49-F238E27FC236}">
+                <a16:creationId xmlns:a16="http://schemas.microsoft.com/office/drawing/2014/main" id="{27B62AAA-5C43-E012-78EF-3F8D8F0AAE18}"/>
+              </a:ext>
+            </a:extLst>
+          </p:cNvPr>
+          <p:cNvSpPr txBox="1"/>
+          <p:nvPr/>
+        </p:nvSpPr>
+        <p:spPr>
+          <a:xfrm>
+            <a:off x="338667" y="237067"/>
+            <a:ext cx="5757333" cy="369332"/>
+          </a:xfrm>
+          <a:prstGeom prst="rect">
+            <a:avLst/>
+          </a:prstGeom>
+          <a:noFill/>
+        </p:spPr>
+        <p:txBody>
+          <a:bodyPr wrap="square" rtlCol="0">
+            <a:spAutoFit/>
+          </a:bodyPr>
+          <a:lstStyle/>
+          <a:p>
+            <a:r>
+              <a:rPr lang="en-US" b="1" dirty="0">
+                <a:latin typeface="Times New Roman" panose="02020603050405020304" pitchFamily="18" charset="0"/>
+                <a:cs typeface="Times New Roman" panose="02020603050405020304" pitchFamily="18" charset="0"/>
+              </a:rPr>
+              <a:t>Slave address push - 4 burst pop – write - resp</a:t>
+            </a:r>
+          </a:p>
+        </p:txBody>
+      </p:sp>
     </p:spTree>
     <p:extLst>
       <p:ext uri="{BB962C8B-B14F-4D97-AF65-F5344CB8AC3E}">
-        <p14:creationId xmlns:p14="http://schemas.microsoft.com/office/powerpoint/2010/main" val="3786220653"/>
+        <p14:creationId xmlns:p14="http://schemas.microsoft.com/office/powerpoint/2010/main" val="2447764043"/>
       </p:ext>
     </p:extLst>
   </p:cSld>
@@ -3539,7 +3616,7 @@
           <p:cNvPr id="3" name="Picture 2">
             <a:extLst>
               <a:ext uri="{FF2B5EF4-FFF2-40B4-BE49-F238E27FC236}">
-                <a16:creationId xmlns:a16="http://schemas.microsoft.com/office/drawing/2014/main" id="{3A2891FA-7498-9CC4-39CA-0E120C9D8F2C}"/>
+                <a16:creationId xmlns:a16="http://schemas.microsoft.com/office/drawing/2014/main" id="{44B75E4A-616F-C07D-93C2-0E42C8E10E31}"/>
               </a:ext>
             </a:extLst>
           </p:cNvPr>
@@ -3556,18 +3633,56 @@
         </p:blipFill>
         <p:spPr>
           <a:xfrm>
-            <a:off x="439369" y="588126"/>
-            <a:ext cx="11313261" cy="6066531"/>
+            <a:off x="762000" y="802756"/>
+            <a:ext cx="10805453" cy="5924898"/>
           </a:xfrm>
           <a:prstGeom prst="rect">
             <a:avLst/>
           </a:prstGeom>
         </p:spPr>
       </p:pic>
+      <p:sp>
+        <p:nvSpPr>
+          <p:cNvPr id="5" name="TextBox 4">
+            <a:extLst>
+              <a:ext uri="{FF2B5EF4-FFF2-40B4-BE49-F238E27FC236}">
+                <a16:creationId xmlns:a16="http://schemas.microsoft.com/office/drawing/2014/main" id="{5119FF21-B078-A1F6-6E60-E417EFF4AEDA}"/>
+              </a:ext>
+            </a:extLst>
+          </p:cNvPr>
+          <p:cNvSpPr txBox="1"/>
+          <p:nvPr/>
+        </p:nvSpPr>
+        <p:spPr>
+          <a:xfrm>
+            <a:off x="338667" y="237067"/>
+            <a:ext cx="7272866" cy="369332"/>
+          </a:xfrm>
+          <a:prstGeom prst="rect">
+            <a:avLst/>
+          </a:prstGeom>
+          <a:noFill/>
+        </p:spPr>
+        <p:txBody>
+          <a:bodyPr wrap="square" rtlCol="0">
+            <a:spAutoFit/>
+          </a:bodyPr>
+          <a:lstStyle/>
+          <a:p>
+            <a:r>
+              <a:rPr lang="en-US" b="1" dirty="0">
+                <a:latin typeface="Times New Roman" panose="02020603050405020304" pitchFamily="18" charset="0"/>
+                <a:cs typeface="Times New Roman" panose="02020603050405020304" pitchFamily="18" charset="0"/>
+              </a:rPr>
+              <a:t>Two outstanding address push - pop (when write valid) - resp</a:t>
+            </a:r>
+          </a:p>
+        </p:txBody>
+      </p:sp>
     </p:spTree>
     <p:extLst>
       <p:ext uri="{BB962C8B-B14F-4D97-AF65-F5344CB8AC3E}">
-        <p14:creationId xmlns:p14="http://schemas.microsoft.com/office/powerpoint/2010/main" val="2447764043"/>
+        <p14:creationId xmlns:p14="http://schemas.microsoft.com/office/powerpoint/2010/main" val="4186278016"/>
       </p:ext>
     </p:extLst>
   </p:cSld>
@@ -3599,7 +3714,7 @@
           <p:cNvPr id="3" name="Picture 2">
             <a:extLst>
               <a:ext uri="{FF2B5EF4-FFF2-40B4-BE49-F238E27FC236}">
-                <a16:creationId xmlns:a16="http://schemas.microsoft.com/office/drawing/2014/main" id="{44B75E4A-616F-C07D-93C2-0E42C8E10E31}"/>
+                <a16:creationId xmlns:a16="http://schemas.microsoft.com/office/drawing/2014/main" id="{DE04FBFB-F07F-58DA-E887-DDFE15A84146}"/>
               </a:ext>
             </a:extLst>
           </p:cNvPr>
@@ -3616,18 +3731,56 @@
         </p:blipFill>
         <p:spPr>
           <a:xfrm>
-            <a:off x="896934" y="745067"/>
-            <a:ext cx="10638565" cy="5833389"/>
+            <a:off x="1260723" y="922867"/>
+            <a:ext cx="9670553" cy="5484167"/>
           </a:xfrm>
           <a:prstGeom prst="rect">
             <a:avLst/>
           </a:prstGeom>
         </p:spPr>
       </p:pic>
+      <p:sp>
+        <p:nvSpPr>
+          <p:cNvPr id="7" name="TextBox 6">
+            <a:extLst>
+              <a:ext uri="{FF2B5EF4-FFF2-40B4-BE49-F238E27FC236}">
+                <a16:creationId xmlns:a16="http://schemas.microsoft.com/office/drawing/2014/main" id="{7FBDF3FB-EAC6-82F4-AB79-6861878216B3}"/>
+              </a:ext>
+            </a:extLst>
+          </p:cNvPr>
+          <p:cNvSpPr txBox="1"/>
+          <p:nvPr/>
+        </p:nvSpPr>
+        <p:spPr>
+          <a:xfrm>
+            <a:off x="338667" y="237067"/>
+            <a:ext cx="7272866" cy="369332"/>
+          </a:xfrm>
+          <a:prstGeom prst="rect">
+            <a:avLst/>
+          </a:prstGeom>
+          <a:noFill/>
+        </p:spPr>
+        <p:txBody>
+          <a:bodyPr wrap="square" rtlCol="0">
+            <a:spAutoFit/>
+          </a:bodyPr>
+          <a:lstStyle/>
+          <a:p>
+            <a:r>
+              <a:rPr lang="en-US" b="1" dirty="0">
+                <a:latin typeface="Times New Roman" panose="02020603050405020304" pitchFamily="18" charset="0"/>
+                <a:cs typeface="Times New Roman" panose="02020603050405020304" pitchFamily="18" charset="0"/>
+              </a:rPr>
+              <a:t>BRESP = SLVERR for WLAST mismatch</a:t>
+            </a:r>
+          </a:p>
+        </p:txBody>
+      </p:sp>
     </p:spTree>
     <p:extLst>
       <p:ext uri="{BB962C8B-B14F-4D97-AF65-F5344CB8AC3E}">
-        <p14:creationId xmlns:p14="http://schemas.microsoft.com/office/powerpoint/2010/main" val="4186278016"/>
+        <p14:creationId xmlns:p14="http://schemas.microsoft.com/office/powerpoint/2010/main" val="3190925855"/>
       </p:ext>
     </p:extLst>
   </p:cSld>
@@ -3659,7 +3812,7 @@
           <p:cNvPr id="3" name="Picture 2">
             <a:extLst>
               <a:ext uri="{FF2B5EF4-FFF2-40B4-BE49-F238E27FC236}">
-                <a16:creationId xmlns:a16="http://schemas.microsoft.com/office/drawing/2014/main" id="{DE04FBFB-F07F-58DA-E887-DDFE15A84146}"/>
+                <a16:creationId xmlns:a16="http://schemas.microsoft.com/office/drawing/2014/main" id="{C7FB7613-606A-E05B-BCE7-6AB1830B1F31}"/>
               </a:ext>
             </a:extLst>
           </p:cNvPr>
@@ -3676,18 +3829,56 @@
         </p:blipFill>
         <p:spPr>
           <a:xfrm>
-            <a:off x="872254" y="711200"/>
-            <a:ext cx="10447491" cy="5924768"/>
+            <a:off x="387094" y="953913"/>
+            <a:ext cx="11417812" cy="4950174"/>
           </a:xfrm>
           <a:prstGeom prst="rect">
             <a:avLst/>
           </a:prstGeom>
         </p:spPr>
       </p:pic>
+      <p:sp>
+        <p:nvSpPr>
+          <p:cNvPr id="5" name="TextBox 4">
+            <a:extLst>
+              <a:ext uri="{FF2B5EF4-FFF2-40B4-BE49-F238E27FC236}">
+                <a16:creationId xmlns:a16="http://schemas.microsoft.com/office/drawing/2014/main" id="{D287B036-5C5A-76CD-3804-AC1743B96966}"/>
+              </a:ext>
+            </a:extLst>
+          </p:cNvPr>
+          <p:cNvSpPr txBox="1"/>
+          <p:nvPr/>
+        </p:nvSpPr>
+        <p:spPr>
+          <a:xfrm>
+            <a:off x="338666" y="237067"/>
+            <a:ext cx="8297333" cy="369332"/>
+          </a:xfrm>
+          <a:prstGeom prst="rect">
+            <a:avLst/>
+          </a:prstGeom>
+          <a:noFill/>
+        </p:spPr>
+        <p:txBody>
+          <a:bodyPr wrap="square" rtlCol="0">
+            <a:spAutoFit/>
+          </a:bodyPr>
+          <a:lstStyle/>
+          <a:p>
+            <a:r>
+              <a:rPr lang="en-US" b="1" dirty="0">
+                <a:latin typeface="Times New Roman" panose="02020603050405020304" pitchFamily="18" charset="0"/>
+                <a:cs typeface="Times New Roman" panose="02020603050405020304" pitchFamily="18" charset="0"/>
+              </a:rPr>
+              <a:t>Error slave consuming addresses and write data with RESP fixed at DECERR</a:t>
+            </a:r>
+          </a:p>
+        </p:txBody>
+      </p:sp>
     </p:spTree>
     <p:extLst>
       <p:ext uri="{BB962C8B-B14F-4D97-AF65-F5344CB8AC3E}">
-        <p14:creationId xmlns:p14="http://schemas.microsoft.com/office/powerpoint/2010/main" val="3190925855"/>
+        <p14:creationId xmlns:p14="http://schemas.microsoft.com/office/powerpoint/2010/main" val="4107629951"/>
       </p:ext>
     </p:extLst>
   </p:cSld>
@@ -3714,12 +3905,50 @@
           <a:chExt cx="0" cy="0"/>
         </a:xfrm>
       </p:grpSpPr>
+      <p:sp>
+        <p:nvSpPr>
+          <p:cNvPr id="4" name="TextBox 3">
+            <a:extLst>
+              <a:ext uri="{FF2B5EF4-FFF2-40B4-BE49-F238E27FC236}">
+                <a16:creationId xmlns:a16="http://schemas.microsoft.com/office/drawing/2014/main" id="{2EA12745-6442-4C60-619D-EADDD28EB99C}"/>
+              </a:ext>
+            </a:extLst>
+          </p:cNvPr>
+          <p:cNvSpPr txBox="1"/>
+          <p:nvPr/>
+        </p:nvSpPr>
+        <p:spPr>
+          <a:xfrm>
+            <a:off x="245534" y="389467"/>
+            <a:ext cx="5757333" cy="369332"/>
+          </a:xfrm>
+          <a:prstGeom prst="rect">
+            <a:avLst/>
+          </a:prstGeom>
+          <a:noFill/>
+        </p:spPr>
+        <p:txBody>
+          <a:bodyPr wrap="square" rtlCol="0">
+            <a:spAutoFit/>
+          </a:bodyPr>
+          <a:lstStyle/>
+          <a:p>
+            <a:r>
+              <a:rPr lang="en-US" b="1" dirty="0">
+                <a:latin typeface="Times New Roman" panose="02020603050405020304" pitchFamily="18" charset="0"/>
+                <a:cs typeface="Times New Roman" panose="02020603050405020304" pitchFamily="18" charset="0"/>
+              </a:rPr>
+              <a:t>Skid – buffer value storing</a:t>
+            </a:r>
+          </a:p>
+        </p:txBody>
+      </p:sp>
       <p:pic>
         <p:nvPicPr>
-          <p:cNvPr id="3" name="Picture 2">
-            <a:extLst>
-              <a:ext uri="{FF2B5EF4-FFF2-40B4-BE49-F238E27FC236}">
-                <a16:creationId xmlns:a16="http://schemas.microsoft.com/office/drawing/2014/main" id="{C7FB7613-606A-E05B-BCE7-6AB1830B1F31}"/>
+          <p:cNvPr id="5" name="Picture 4">
+            <a:extLst>
+              <a:ext uri="{FF2B5EF4-FFF2-40B4-BE49-F238E27FC236}">
+                <a16:creationId xmlns:a16="http://schemas.microsoft.com/office/drawing/2014/main" id="{BBEC078C-1AF6-2C70-4CA8-E21BA91CE47F}"/>
               </a:ext>
             </a:extLst>
           </p:cNvPr>
@@ -3736,8 +3965,8 @@
         </p:blipFill>
         <p:spPr>
           <a:xfrm>
-            <a:off x="387094" y="953913"/>
-            <a:ext cx="11417812" cy="4950174"/>
+            <a:off x="1155043" y="1316477"/>
+            <a:ext cx="9482877" cy="4225045"/>
           </a:xfrm>
           <a:prstGeom prst="rect">
             <a:avLst/>
@@ -3747,7 +3976,271 @@
     </p:spTree>
     <p:extLst>
       <p:ext uri="{BB962C8B-B14F-4D97-AF65-F5344CB8AC3E}">
-        <p14:creationId xmlns:p14="http://schemas.microsoft.com/office/powerpoint/2010/main" val="4107629951"/>
+        <p14:creationId xmlns:p14="http://schemas.microsoft.com/office/powerpoint/2010/main" val="2865469070"/>
+      </p:ext>
+    </p:extLst>
+  </p:cSld>
+  <p:clrMapOvr>
+    <a:masterClrMapping/>
+  </p:clrMapOvr>
+</p:sld>
+</file>
+
+<file path=ppt/slides/slide8.xml><?xml version="1.0" encoding="utf-8"?>
+<p:sld xmlns:a="http://schemas.openxmlformats.org/drawingml/2006/main" xmlns:r="http://schemas.openxmlformats.org/officeDocument/2006/relationships" xmlns:p="http://schemas.openxmlformats.org/presentationml/2006/main">
+  <p:cSld>
+    <p:spTree>
+      <p:nvGrpSpPr>
+        <p:cNvPr id="1" name=""/>
+        <p:cNvGrpSpPr/>
+        <p:nvPr/>
+      </p:nvGrpSpPr>
+      <p:grpSpPr>
+        <a:xfrm>
+          <a:off x="0" y="0"/>
+          <a:ext cx="0" cy="0"/>
+          <a:chOff x="0" y="0"/>
+          <a:chExt cx="0" cy="0"/>
+        </a:xfrm>
+      </p:grpSpPr>
+      <p:sp>
+        <p:nvSpPr>
+          <p:cNvPr id="3" name="TextBox 2">
+            <a:extLst>
+              <a:ext uri="{FF2B5EF4-FFF2-40B4-BE49-F238E27FC236}">
+                <a16:creationId xmlns:a16="http://schemas.microsoft.com/office/drawing/2014/main" id="{55504857-5FC4-D9C0-BDE9-FC40C8999288}"/>
+              </a:ext>
+            </a:extLst>
+          </p:cNvPr>
+          <p:cNvSpPr txBox="1"/>
+          <p:nvPr/>
+        </p:nvSpPr>
+        <p:spPr>
+          <a:xfrm>
+            <a:off x="3234019" y="782884"/>
+            <a:ext cx="5757333" cy="369332"/>
+          </a:xfrm>
+          <a:prstGeom prst="rect">
+            <a:avLst/>
+          </a:prstGeom>
+          <a:noFill/>
+        </p:spPr>
+        <p:txBody>
+          <a:bodyPr wrap="square" rtlCol="0">
+            <a:spAutoFit/>
+          </a:bodyPr>
+          <a:lstStyle/>
+          <a:p>
+            <a:r>
+              <a:rPr lang="en-US" b="1" dirty="0">
+                <a:latin typeface="Times New Roman" panose="02020603050405020304" pitchFamily="18" charset="0"/>
+                <a:cs typeface="Times New Roman" panose="02020603050405020304" pitchFamily="18" charset="0"/>
+              </a:rPr>
+              <a:t>Address decoder after skid buffered address</a:t>
+            </a:r>
+          </a:p>
+        </p:txBody>
+      </p:sp>
+      <p:pic>
+        <p:nvPicPr>
+          <p:cNvPr id="5" name="Picture 4">
+            <a:extLst>
+              <a:ext uri="{FF2B5EF4-FFF2-40B4-BE49-F238E27FC236}">
+                <a16:creationId xmlns:a16="http://schemas.microsoft.com/office/drawing/2014/main" id="{98489013-DF93-E913-B589-47776011B7AD}"/>
+              </a:ext>
+            </a:extLst>
+          </p:cNvPr>
+          <p:cNvPicPr>
+            <a:picLocks noChangeAspect="1"/>
+          </p:cNvPicPr>
+          <p:nvPr/>
+        </p:nvPicPr>
+        <p:blipFill>
+          <a:blip r:embed="rId2"/>
+          <a:stretch>
+            <a:fillRect/>
+          </a:stretch>
+        </p:blipFill>
+        <p:spPr>
+          <a:xfrm>
+            <a:off x="1298275" y="1303867"/>
+            <a:ext cx="8896803" cy="1742088"/>
+          </a:xfrm>
+          <a:prstGeom prst="rect">
+            <a:avLst/>
+          </a:prstGeom>
+        </p:spPr>
+      </p:pic>
+      <p:pic>
+        <p:nvPicPr>
+          <p:cNvPr id="7" name="Picture 6">
+            <a:extLst>
+              <a:ext uri="{FF2B5EF4-FFF2-40B4-BE49-F238E27FC236}">
+                <a16:creationId xmlns:a16="http://schemas.microsoft.com/office/drawing/2014/main" id="{E8B98BE3-DD59-4756-C584-662F1EA5443A}"/>
+              </a:ext>
+            </a:extLst>
+          </p:cNvPr>
+          <p:cNvPicPr>
+            <a:picLocks noChangeAspect="1"/>
+          </p:cNvPicPr>
+          <p:nvPr/>
+        </p:nvPicPr>
+        <p:blipFill>
+          <a:blip r:embed="rId3"/>
+          <a:srcRect l="11579" t="9175" r="6114" b="6693"/>
+          <a:stretch>
+            <a:fillRect/>
+          </a:stretch>
+        </p:blipFill>
+        <p:spPr>
+          <a:xfrm>
+            <a:off x="2768600" y="3733800"/>
+            <a:ext cx="6079067" cy="1797798"/>
+          </a:xfrm>
+          <a:prstGeom prst="rect">
+            <a:avLst/>
+          </a:prstGeom>
+        </p:spPr>
+      </p:pic>
+    </p:spTree>
+    <p:extLst>
+      <p:ext uri="{BB962C8B-B14F-4D97-AF65-F5344CB8AC3E}">
+        <p14:creationId xmlns:p14="http://schemas.microsoft.com/office/powerpoint/2010/main" val="2829762061"/>
+      </p:ext>
+    </p:extLst>
+  </p:cSld>
+  <p:clrMapOvr>
+    <a:masterClrMapping/>
+  </p:clrMapOvr>
+</p:sld>
+</file>
+
+<file path=ppt/slides/slide9.xml><?xml version="1.0" encoding="utf-8"?>
+<p:sld xmlns:a="http://schemas.openxmlformats.org/drawingml/2006/main" xmlns:r="http://schemas.openxmlformats.org/officeDocument/2006/relationships" xmlns:p="http://schemas.openxmlformats.org/presentationml/2006/main">
+  <p:cSld>
+    <p:spTree>
+      <p:nvGrpSpPr>
+        <p:cNvPr id="1" name="">
+          <a:extLst>
+            <a:ext uri="{FF2B5EF4-FFF2-40B4-BE49-F238E27FC236}">
+              <a16:creationId xmlns:a16="http://schemas.microsoft.com/office/drawing/2014/main" id="{A1AEB1BD-3842-256E-CB48-59E5D78FF166}"/>
+            </a:ext>
+          </a:extLst>
+        </p:cNvPr>
+        <p:cNvGrpSpPr/>
+        <p:nvPr/>
+      </p:nvGrpSpPr>
+      <p:grpSpPr>
+        <a:xfrm>
+          <a:off x="0" y="0"/>
+          <a:ext cx="0" cy="0"/>
+          <a:chOff x="0" y="0"/>
+          <a:chExt cx="0" cy="0"/>
+        </a:xfrm>
+      </p:grpSpPr>
+      <p:sp>
+        <p:nvSpPr>
+          <p:cNvPr id="3" name="TextBox 2">
+            <a:extLst>
+              <a:ext uri="{FF2B5EF4-FFF2-40B4-BE49-F238E27FC236}">
+                <a16:creationId xmlns:a16="http://schemas.microsoft.com/office/drawing/2014/main" id="{D82BE859-3BA6-8F2A-4973-FEC7193B7752}"/>
+              </a:ext>
+            </a:extLst>
+          </p:cNvPr>
+          <p:cNvSpPr txBox="1"/>
+          <p:nvPr/>
+        </p:nvSpPr>
+        <p:spPr>
+          <a:xfrm>
+            <a:off x="448734" y="846667"/>
+            <a:ext cx="5757333" cy="369332"/>
+          </a:xfrm>
+          <a:prstGeom prst="rect">
+            <a:avLst/>
+          </a:prstGeom>
+          <a:noFill/>
+        </p:spPr>
+        <p:txBody>
+          <a:bodyPr wrap="square" rtlCol="0">
+            <a:spAutoFit/>
+          </a:bodyPr>
+          <a:lstStyle/>
+          <a:p>
+            <a:r>
+              <a:rPr lang="en-US" b="1" dirty="0">
+                <a:latin typeface="Times New Roman" panose="02020603050405020304" pitchFamily="18" charset="0"/>
+                <a:cs typeface="Times New Roman" panose="02020603050405020304" pitchFamily="18" charset="0"/>
+              </a:rPr>
+              <a:t>Response Arbiter S0 &gt; S1 &gt; ERR</a:t>
+            </a:r>
+          </a:p>
+        </p:txBody>
+      </p:sp>
+      <p:pic>
+        <p:nvPicPr>
+          <p:cNvPr id="4" name="Picture 3">
+            <a:extLst>
+              <a:ext uri="{FF2B5EF4-FFF2-40B4-BE49-F238E27FC236}">
+                <a16:creationId xmlns:a16="http://schemas.microsoft.com/office/drawing/2014/main" id="{368F49CA-116F-9753-FA14-0DA5D9A61637}"/>
+              </a:ext>
+            </a:extLst>
+          </p:cNvPr>
+          <p:cNvPicPr>
+            <a:picLocks noChangeAspect="1"/>
+          </p:cNvPicPr>
+          <p:nvPr/>
+        </p:nvPicPr>
+        <p:blipFill>
+          <a:blip r:embed="rId2"/>
+          <a:stretch>
+            <a:fillRect/>
+          </a:stretch>
+        </p:blipFill>
+        <p:spPr>
+          <a:xfrm>
+            <a:off x="448734" y="1701749"/>
+            <a:ext cx="9619808" cy="4766784"/>
+          </a:xfrm>
+          <a:prstGeom prst="rect">
+            <a:avLst/>
+          </a:prstGeom>
+        </p:spPr>
+      </p:pic>
+      <p:pic>
+        <p:nvPicPr>
+          <p:cNvPr id="8" name="Picture 7">
+            <a:extLst>
+              <a:ext uri="{FF2B5EF4-FFF2-40B4-BE49-F238E27FC236}">
+                <a16:creationId xmlns:a16="http://schemas.microsoft.com/office/drawing/2014/main" id="{227861D3-64F0-BF7C-92B7-CDBFD0868FB1}"/>
+              </a:ext>
+            </a:extLst>
+          </p:cNvPr>
+          <p:cNvPicPr>
+            <a:picLocks noChangeAspect="1"/>
+          </p:cNvPicPr>
+          <p:nvPr/>
+        </p:nvPicPr>
+        <p:blipFill>
+          <a:blip r:embed="rId3"/>
+          <a:srcRect l="12920" t="11414" b="12078"/>
+          <a:stretch>
+            <a:fillRect/>
+          </a:stretch>
+        </p:blipFill>
+        <p:spPr>
+          <a:xfrm>
+            <a:off x="4292600" y="418052"/>
+            <a:ext cx="6001324" cy="1100667"/>
+          </a:xfrm>
+          <a:prstGeom prst="rect">
+            <a:avLst/>
+          </a:prstGeom>
+        </p:spPr>
+      </p:pic>
+    </p:spTree>
+    <p:extLst>
+      <p:ext uri="{BB962C8B-B14F-4D97-AF65-F5344CB8AC3E}">
+        <p14:creationId xmlns:p14="http://schemas.microsoft.com/office/powerpoint/2010/main" val="1088384191"/>
       </p:ext>
     </p:extLst>
   </p:cSld>

</xml_diff>

<commit_message>
Add top interconnect fabric and fix master port names
</commit_message>
<xml_diff>
--- a/doc/AXI.pptx
+++ b/doc/AXI.pptx
@@ -14,6 +14,7 @@
     <p:sldId id="257" r:id="rId8"/>
     <p:sldId id="263" r:id="rId9"/>
     <p:sldId id="264" r:id="rId10"/>
+    <p:sldId id="265" r:id="rId11"/>
   </p:sldIdLst>
   <p:sldSz cx="12192000" cy="6858000"/>
   <p:notesSz cx="6858000" cy="9144000"/>
@@ -267,7 +268,7 @@
           <a:p>
             <a:fld id="{F120C451-DCB1-4D59-8D1B-95032E339999}" type="datetimeFigureOut">
               <a:rPr lang="en-US" smtClean="0"/>
-              <a:t>8/18/2026</a:t>
+              <a:t>8/19/2026</a:t>
             </a:fld>
             <a:endParaRPr lang="en-US"/>
           </a:p>
@@ -465,7 +466,7 @@
           <a:p>
             <a:fld id="{F120C451-DCB1-4D59-8D1B-95032E339999}" type="datetimeFigureOut">
               <a:rPr lang="en-US" smtClean="0"/>
-              <a:t>8/18/2026</a:t>
+              <a:t>8/19/2026</a:t>
             </a:fld>
             <a:endParaRPr lang="en-US"/>
           </a:p>
@@ -673,7 +674,7 @@
           <a:p>
             <a:fld id="{F120C451-DCB1-4D59-8D1B-95032E339999}" type="datetimeFigureOut">
               <a:rPr lang="en-US" smtClean="0"/>
-              <a:t>8/18/2026</a:t>
+              <a:t>8/19/2026</a:t>
             </a:fld>
             <a:endParaRPr lang="en-US"/>
           </a:p>
@@ -871,7 +872,7 @@
           <a:p>
             <a:fld id="{F120C451-DCB1-4D59-8D1B-95032E339999}" type="datetimeFigureOut">
               <a:rPr lang="en-US" smtClean="0"/>
-              <a:t>8/18/2026</a:t>
+              <a:t>8/19/2026</a:t>
             </a:fld>
             <a:endParaRPr lang="en-US"/>
           </a:p>
@@ -1146,7 +1147,7 @@
           <a:p>
             <a:fld id="{F120C451-DCB1-4D59-8D1B-95032E339999}" type="datetimeFigureOut">
               <a:rPr lang="en-US" smtClean="0"/>
-              <a:t>8/18/2026</a:t>
+              <a:t>8/19/2026</a:t>
             </a:fld>
             <a:endParaRPr lang="en-US"/>
           </a:p>
@@ -1411,7 +1412,7 @@
           <a:p>
             <a:fld id="{F120C451-DCB1-4D59-8D1B-95032E339999}" type="datetimeFigureOut">
               <a:rPr lang="en-US" smtClean="0"/>
-              <a:t>8/18/2026</a:t>
+              <a:t>8/19/2026</a:t>
             </a:fld>
             <a:endParaRPr lang="en-US"/>
           </a:p>
@@ -1823,7 +1824,7 @@
           <a:p>
             <a:fld id="{F120C451-DCB1-4D59-8D1B-95032E339999}" type="datetimeFigureOut">
               <a:rPr lang="en-US" smtClean="0"/>
-              <a:t>8/18/2026</a:t>
+              <a:t>8/19/2026</a:t>
             </a:fld>
             <a:endParaRPr lang="en-US"/>
           </a:p>
@@ -1964,7 +1965,7 @@
           <a:p>
             <a:fld id="{F120C451-DCB1-4D59-8D1B-95032E339999}" type="datetimeFigureOut">
               <a:rPr lang="en-US" smtClean="0"/>
-              <a:t>8/18/2026</a:t>
+              <a:t>8/19/2026</a:t>
             </a:fld>
             <a:endParaRPr lang="en-US"/>
           </a:p>
@@ -2077,7 +2078,7 @@
           <a:p>
             <a:fld id="{F120C451-DCB1-4D59-8D1B-95032E339999}" type="datetimeFigureOut">
               <a:rPr lang="en-US" smtClean="0"/>
-              <a:t>8/18/2026</a:t>
+              <a:t>8/19/2026</a:t>
             </a:fld>
             <a:endParaRPr lang="en-US"/>
           </a:p>
@@ -2388,7 +2389,7 @@
           <a:p>
             <a:fld id="{F120C451-DCB1-4D59-8D1B-95032E339999}" type="datetimeFigureOut">
               <a:rPr lang="en-US" smtClean="0"/>
-              <a:t>8/18/2026</a:t>
+              <a:t>8/19/2026</a:t>
             </a:fld>
             <a:endParaRPr lang="en-US"/>
           </a:p>
@@ -2676,7 +2677,7 @@
           <a:p>
             <a:fld id="{F120C451-DCB1-4D59-8D1B-95032E339999}" type="datetimeFigureOut">
               <a:rPr lang="en-US" smtClean="0"/>
-              <a:t>8/18/2026</a:t>
+              <a:t>8/19/2026</a:t>
             </a:fld>
             <a:endParaRPr lang="en-US"/>
           </a:p>
@@ -2917,7 +2918,7 @@
           <a:p>
             <a:fld id="{F120C451-DCB1-4D59-8D1B-95032E339999}" type="datetimeFigureOut">
               <a:rPr lang="en-US" smtClean="0"/>
-              <a:t>8/18/2026</a:t>
+              <a:t>8/19/2026</a:t>
             </a:fld>
             <a:endParaRPr lang="en-US"/>
           </a:p>
@@ -3388,6 +3389,104 @@
     <p:extLst>
       <p:ext uri="{BB962C8B-B14F-4D97-AF65-F5344CB8AC3E}">
         <p14:creationId xmlns:p14="http://schemas.microsoft.com/office/powerpoint/2010/main" val="1992602617"/>
+      </p:ext>
+    </p:extLst>
+  </p:cSld>
+  <p:clrMapOvr>
+    <a:masterClrMapping/>
+  </p:clrMapOvr>
+</p:sld>
+</file>
+
+<file path=ppt/slides/slide10.xml><?xml version="1.0" encoding="utf-8"?>
+<p:sld xmlns:a="http://schemas.openxmlformats.org/drawingml/2006/main" xmlns:r="http://schemas.openxmlformats.org/officeDocument/2006/relationships" xmlns:p="http://schemas.openxmlformats.org/presentationml/2006/main">
+  <p:cSld>
+    <p:spTree>
+      <p:nvGrpSpPr>
+        <p:cNvPr id="1" name=""/>
+        <p:cNvGrpSpPr/>
+        <p:nvPr/>
+      </p:nvGrpSpPr>
+      <p:grpSpPr>
+        <a:xfrm>
+          <a:off x="0" y="0"/>
+          <a:ext cx="0" cy="0"/>
+          <a:chOff x="0" y="0"/>
+          <a:chExt cx="0" cy="0"/>
+        </a:xfrm>
+      </p:grpSpPr>
+      <p:sp>
+        <p:nvSpPr>
+          <p:cNvPr id="5" name="TextBox 4">
+            <a:extLst>
+              <a:ext uri="{FF2B5EF4-FFF2-40B4-BE49-F238E27FC236}">
+                <a16:creationId xmlns:a16="http://schemas.microsoft.com/office/drawing/2014/main" id="{1D22FD84-A28B-942F-BDCA-5BCB3A798068}"/>
+              </a:ext>
+            </a:extLst>
+          </p:cNvPr>
+          <p:cNvSpPr txBox="1"/>
+          <p:nvPr/>
+        </p:nvSpPr>
+        <p:spPr>
+          <a:xfrm>
+            <a:off x="254001" y="211663"/>
+            <a:ext cx="5757333" cy="369332"/>
+          </a:xfrm>
+          <a:prstGeom prst="rect">
+            <a:avLst/>
+          </a:prstGeom>
+          <a:noFill/>
+        </p:spPr>
+        <p:txBody>
+          <a:bodyPr wrap="square" rtlCol="0">
+            <a:spAutoFit/>
+          </a:bodyPr>
+          <a:lstStyle/>
+          <a:p>
+            <a:r>
+              <a:rPr lang="en-US" b="1" dirty="0">
+                <a:latin typeface="Times New Roman" panose="02020603050405020304" pitchFamily="18" charset="0"/>
+                <a:cs typeface="Times New Roman" panose="02020603050405020304" pitchFamily="18" charset="0"/>
+              </a:rPr>
+              <a:t>6 LEN Burst Write in Slave0 from interconnect top</a:t>
+            </a:r>
+          </a:p>
+        </p:txBody>
+      </p:sp>
+      <p:pic>
+        <p:nvPicPr>
+          <p:cNvPr id="11" name="Picture 10">
+            <a:extLst>
+              <a:ext uri="{FF2B5EF4-FFF2-40B4-BE49-F238E27FC236}">
+                <a16:creationId xmlns:a16="http://schemas.microsoft.com/office/drawing/2014/main" id="{A1DD67ED-B421-0BE0-050F-BE9F64859F7F}"/>
+              </a:ext>
+            </a:extLst>
+          </p:cNvPr>
+          <p:cNvPicPr>
+            <a:picLocks noChangeAspect="1"/>
+          </p:cNvPicPr>
+          <p:nvPr/>
+        </p:nvPicPr>
+        <p:blipFill>
+          <a:blip r:embed="rId2"/>
+          <a:stretch>
+            <a:fillRect/>
+          </a:stretch>
+        </p:blipFill>
+        <p:spPr>
+          <a:xfrm>
+            <a:off x="982133" y="660011"/>
+            <a:ext cx="9912163" cy="5897460"/>
+          </a:xfrm>
+          <a:prstGeom prst="rect">
+            <a:avLst/>
+          </a:prstGeom>
+        </p:spPr>
+      </p:pic>
+    </p:spTree>
+    <p:extLst>
+      <p:ext uri="{BB962C8B-B14F-4D97-AF65-F5344CB8AC3E}">
+        <p14:creationId xmlns:p14="http://schemas.microsoft.com/office/powerpoint/2010/main" val="627423921"/>
       </p:ext>
     </p:extLst>
   </p:cSld>

</xml_diff>

<commit_message>
add reordering + anti-starvation
</commit_message>
<xml_diff>
--- a/doc/AXI.pptx
+++ b/doc/AXI.pptx
@@ -268,7 +268,7 @@
           <a:p>
             <a:fld id="{F120C451-DCB1-4D59-8D1B-95032E339999}" type="datetimeFigureOut">
               <a:rPr lang="en-US" smtClean="0"/>
-              <a:t>8/20/2026</a:t>
+              <a:t>8/24/2026</a:t>
             </a:fld>
             <a:endParaRPr lang="en-US"/>
           </a:p>
@@ -466,7 +466,7 @@
           <a:p>
             <a:fld id="{F120C451-DCB1-4D59-8D1B-95032E339999}" type="datetimeFigureOut">
               <a:rPr lang="en-US" smtClean="0"/>
-              <a:t>8/20/2026</a:t>
+              <a:t>8/24/2026</a:t>
             </a:fld>
             <a:endParaRPr lang="en-US"/>
           </a:p>
@@ -674,7 +674,7 @@
           <a:p>
             <a:fld id="{F120C451-DCB1-4D59-8D1B-95032E339999}" type="datetimeFigureOut">
               <a:rPr lang="en-US" smtClean="0"/>
-              <a:t>8/20/2026</a:t>
+              <a:t>8/24/2026</a:t>
             </a:fld>
             <a:endParaRPr lang="en-US"/>
           </a:p>
@@ -872,7 +872,7 @@
           <a:p>
             <a:fld id="{F120C451-DCB1-4D59-8D1B-95032E339999}" type="datetimeFigureOut">
               <a:rPr lang="en-US" smtClean="0"/>
-              <a:t>8/20/2026</a:t>
+              <a:t>8/24/2026</a:t>
             </a:fld>
             <a:endParaRPr lang="en-US"/>
           </a:p>
@@ -1147,7 +1147,7 @@
           <a:p>
             <a:fld id="{F120C451-DCB1-4D59-8D1B-95032E339999}" type="datetimeFigureOut">
               <a:rPr lang="en-US" smtClean="0"/>
-              <a:t>8/20/2026</a:t>
+              <a:t>8/24/2026</a:t>
             </a:fld>
             <a:endParaRPr lang="en-US"/>
           </a:p>
@@ -1412,7 +1412,7 @@
           <a:p>
             <a:fld id="{F120C451-DCB1-4D59-8D1B-95032E339999}" type="datetimeFigureOut">
               <a:rPr lang="en-US" smtClean="0"/>
-              <a:t>8/20/2026</a:t>
+              <a:t>8/24/2026</a:t>
             </a:fld>
             <a:endParaRPr lang="en-US"/>
           </a:p>
@@ -1824,7 +1824,7 @@
           <a:p>
             <a:fld id="{F120C451-DCB1-4D59-8D1B-95032E339999}" type="datetimeFigureOut">
               <a:rPr lang="en-US" smtClean="0"/>
-              <a:t>8/20/2026</a:t>
+              <a:t>8/24/2026</a:t>
             </a:fld>
             <a:endParaRPr lang="en-US"/>
           </a:p>
@@ -1965,7 +1965,7 @@
           <a:p>
             <a:fld id="{F120C451-DCB1-4D59-8D1B-95032E339999}" type="datetimeFigureOut">
               <a:rPr lang="en-US" smtClean="0"/>
-              <a:t>8/20/2026</a:t>
+              <a:t>8/24/2026</a:t>
             </a:fld>
             <a:endParaRPr lang="en-US"/>
           </a:p>
@@ -2078,7 +2078,7 @@
           <a:p>
             <a:fld id="{F120C451-DCB1-4D59-8D1B-95032E339999}" type="datetimeFigureOut">
               <a:rPr lang="en-US" smtClean="0"/>
-              <a:t>8/20/2026</a:t>
+              <a:t>8/24/2026</a:t>
             </a:fld>
             <a:endParaRPr lang="en-US"/>
           </a:p>
@@ -2389,7 +2389,7 @@
           <a:p>
             <a:fld id="{F120C451-DCB1-4D59-8D1B-95032E339999}" type="datetimeFigureOut">
               <a:rPr lang="en-US" smtClean="0"/>
-              <a:t>8/20/2026</a:t>
+              <a:t>8/24/2026</a:t>
             </a:fld>
             <a:endParaRPr lang="en-US"/>
           </a:p>
@@ -2677,7 +2677,7 @@
           <a:p>
             <a:fld id="{F120C451-DCB1-4D59-8D1B-95032E339999}" type="datetimeFigureOut">
               <a:rPr lang="en-US" smtClean="0"/>
-              <a:t>8/20/2026</a:t>
+              <a:t>8/24/2026</a:t>
             </a:fld>
             <a:endParaRPr lang="en-US"/>
           </a:p>
@@ -2918,7 +2918,7 @@
           <a:p>
             <a:fld id="{F120C451-DCB1-4D59-8D1B-95032E339999}" type="datetimeFigureOut">
               <a:rPr lang="en-US" smtClean="0"/>
-              <a:t>8/20/2026</a:t>
+              <a:t>8/24/2026</a:t>
             </a:fld>
             <a:endParaRPr lang="en-US"/>
           </a:p>
@@ -3429,7 +3429,7 @@
         </p:nvSpPr>
         <p:spPr>
           <a:xfrm>
-            <a:off x="254001" y="211663"/>
+            <a:off x="3759201" y="231410"/>
             <a:ext cx="5757333" cy="369332"/>
           </a:xfrm>
           <a:prstGeom prst="rect">

</xml_diff>